<commit_message>
Point Wednesday's brush-up at the diagnostic's tracks and report
Tracks come from the key workbook's Python brush-up call, the make-up is
the diagnostic itself, and the one-to-one reads the report email and the
Profile line. The deck, notebook, exercise and data no longer name a
Tuesday paper, and the half-one deck is rebuilt.

Co-Authored-By: Claude Opus 5.5 <noreply@anthropic.com>
Claude-Session: https://claude.ai/code/session_01P7zaoR4dQ5pzBFnsX549JQ
</commit_message>
<xml_diff>
--- a/content/W00/D3/slides/C2_W00_D03_half1_STUDENT.pptx
+++ b/content/W00/D3/slides/C2_W00_D03_half1_STUDENT.pptx
@@ -8738,7 +8738,7 @@
                 </a:solidFill>
                 <a:latin typeface="Calibri"/>
               </a:rPr>
-              <a:t>You are the one person in the building who can write Python. The log is the table from Tuesday's SQL paper.</a:t>
+              <a:t>You are the one person in the building who can write Python. The log holds one row per book lent out.</a:t>
             </a:r>
           </a:p>
         </p:txBody>
@@ -12835,7 +12835,7 @@
                 </a:solidFill>
                 <a:latin typeface="Calibri"/>
               </a:rPr>
-              <a:t>A key names a field, and the value sits beside it. One row of Tuesday's table is one dictionary.</a:t>
+              <a:t>A key names a field, and the value sits beside it. One row of the log is one dictionary.</a:t>
             </a:r>
           </a:p>
         </p:txBody>

</xml_diff>

<commit_message>
Rebuild all 22 decks with sharp diagrams
Every deck with a markdown source is rebuilt with the fixed builder. Every
slide's XML matches the previous build apart from the picture's image
reference and its file-name description, so layouts, type sizes and text are
unchanged; all 110 diagrams now land at 288 to 297 pixels to the inch. The
decks total 10.8 MB, up from 3.0 MB. The orientation deck has no markdown
source and is untouched. Wednesday's provenance note records the fix.

Co-Authored-By: Claude Opus 5.5 <noreply@anthropic.com>
Claude-Session: https://claude.ai/code/session_01P7zaoR4dQ5pzBFnsX549JQ
</commit_message>
<xml_diff>
--- a/content/W00/D3/slides/C2_W00_D03_half1_STUDENT.pptx
+++ b/content/W00/D3/slides/C2_W00_D03_half1_STUDENT.pptx
@@ -3705,14 +3705,14 @@
       </p:sp>
       <p:pic>
         <p:nvPicPr>
-          <p:cNvPr id="6" name="Picture 5" descr="2dca618d529b601e.png"/>
+          <p:cNvPr id="6" name="Picture 5" descr="7f9b88ee653f7cd1.png"/>
           <p:cNvPicPr>
             <a:picLocks noChangeAspect="1"/>
           </p:cNvPicPr>
           <p:nvPr/>
         </p:nvPicPr>
         <p:blipFill>
-          <a:blip r:embed="rId2"/>
+          <a:blip r:embed="rId3"/>
           <a:stretch>
             <a:fillRect/>
           </a:stretch>
@@ -7867,14 +7867,14 @@
       </p:sp>
       <p:pic>
         <p:nvPicPr>
-          <p:cNvPr id="7" name="Picture 6" descr="188ff045cd04c578.png"/>
+          <p:cNvPr id="7" name="Picture 6" descr="131fc8fea8904e6a.png"/>
           <p:cNvPicPr>
             <a:picLocks noChangeAspect="1"/>
           </p:cNvPicPr>
           <p:nvPr/>
         </p:nvPicPr>
         <p:blipFill>
-          <a:blip r:embed="rId2"/>
+          <a:blip r:embed="rId3"/>
           <a:stretch>
             <a:fillRect/>
           </a:stretch>
@@ -9051,14 +9051,14 @@
       </p:sp>
       <p:pic>
         <p:nvPicPr>
-          <p:cNvPr id="6" name="Picture 5" descr="dfb6af358858f232.png"/>
+          <p:cNvPr id="6" name="Picture 5" descr="d94cfe7528ad41c2.png"/>
           <p:cNvPicPr>
             <a:picLocks noChangeAspect="1"/>
           </p:cNvPicPr>
           <p:nvPr/>
         </p:nvPicPr>
         <p:blipFill>
-          <a:blip r:embed="rId2"/>
+          <a:blip r:embed="rId3"/>
           <a:stretch>
             <a:fillRect/>
           </a:stretch>
@@ -9970,14 +9970,14 @@
       </p:sp>
       <p:pic>
         <p:nvPicPr>
-          <p:cNvPr id="6" name="Picture 5" descr="1ffc690f23944cc9.png"/>
+          <p:cNvPr id="6" name="Picture 5" descr="b55d6587d2283d49.png"/>
           <p:cNvPicPr>
             <a:picLocks noChangeAspect="1"/>
           </p:cNvPicPr>
           <p:nvPr/>
         </p:nvPicPr>
         <p:blipFill>
-          <a:blip r:embed="rId2"/>
+          <a:blip r:embed="rId3"/>
           <a:stretch>
             <a:fillRect/>
           </a:stretch>
@@ -12636,14 +12636,14 @@
       </p:sp>
       <p:pic>
         <p:nvPicPr>
-          <p:cNvPr id="6" name="Picture 5" descr="972b17c39f1fba50.png"/>
+          <p:cNvPr id="6" name="Picture 5" descr="2ce2de7501e6a77a.png"/>
           <p:cNvPicPr>
             <a:picLocks noChangeAspect="1"/>
           </p:cNvPicPr>
           <p:nvPr/>
         </p:nvPicPr>
         <p:blipFill>
-          <a:blip r:embed="rId2"/>
+          <a:blip r:embed="rId3"/>
           <a:stretch>
             <a:fillRect/>
           </a:stretch>

</xml_diff>